<commit_message>
Flex and Python conceptual model files
Added Python file and updates other files.

Change-Id: I50e933ba69252280f1e3db3b463db4a47fa051c7
</commit_message>
<xml_diff>
--- a/HelpResourcesSources/TechnicalNotes/FLEx 9.1 Conceptual Model - Lexicon model.pptx
+++ b/HelpResourcesSources/TechnicalNotes/FLEx 9.1 Conceptual Model - Lexicon model.pptx
@@ -307,7 +307,7 @@
           <a:p>
             <a:fld id="{C9619C31-9712-4FF2-9651-92B20A921DDE}" type="datetimeFigureOut">
               <a:rPr lang="en-US" smtClean="0"/>
-              <a:t>5/14/2024</a:t>
+              <a:t>6/18/2024</a:t>
             </a:fld>
             <a:endParaRPr lang="en-US"/>
           </a:p>
@@ -505,7 +505,7 @@
           <a:p>
             <a:fld id="{C9619C31-9712-4FF2-9651-92B20A921DDE}" type="datetimeFigureOut">
               <a:rPr lang="en-US" smtClean="0"/>
-              <a:t>5/14/2024</a:t>
+              <a:t>6/18/2024</a:t>
             </a:fld>
             <a:endParaRPr lang="en-US"/>
           </a:p>
@@ -713,7 +713,7 @@
           <a:p>
             <a:fld id="{C9619C31-9712-4FF2-9651-92B20A921DDE}" type="datetimeFigureOut">
               <a:rPr lang="en-US" smtClean="0"/>
-              <a:t>5/14/2024</a:t>
+              <a:t>6/18/2024</a:t>
             </a:fld>
             <a:endParaRPr lang="en-US"/>
           </a:p>
@@ -911,7 +911,7 @@
           <a:p>
             <a:fld id="{C9619C31-9712-4FF2-9651-92B20A921DDE}" type="datetimeFigureOut">
               <a:rPr lang="en-US" smtClean="0"/>
-              <a:t>5/14/2024</a:t>
+              <a:t>6/18/2024</a:t>
             </a:fld>
             <a:endParaRPr lang="en-US"/>
           </a:p>
@@ -1186,7 +1186,7 @@
           <a:p>
             <a:fld id="{C9619C31-9712-4FF2-9651-92B20A921DDE}" type="datetimeFigureOut">
               <a:rPr lang="en-US" smtClean="0"/>
-              <a:t>5/14/2024</a:t>
+              <a:t>6/18/2024</a:t>
             </a:fld>
             <a:endParaRPr lang="en-US"/>
           </a:p>
@@ -1451,7 +1451,7 @@
           <a:p>
             <a:fld id="{C9619C31-9712-4FF2-9651-92B20A921DDE}" type="datetimeFigureOut">
               <a:rPr lang="en-US" smtClean="0"/>
-              <a:t>5/14/2024</a:t>
+              <a:t>6/18/2024</a:t>
             </a:fld>
             <a:endParaRPr lang="en-US"/>
           </a:p>
@@ -1863,7 +1863,7 @@
           <a:p>
             <a:fld id="{C9619C31-9712-4FF2-9651-92B20A921DDE}" type="datetimeFigureOut">
               <a:rPr lang="en-US" smtClean="0"/>
-              <a:t>5/14/2024</a:t>
+              <a:t>6/18/2024</a:t>
             </a:fld>
             <a:endParaRPr lang="en-US"/>
           </a:p>
@@ -2004,7 +2004,7 @@
           <a:p>
             <a:fld id="{C9619C31-9712-4FF2-9651-92B20A921DDE}" type="datetimeFigureOut">
               <a:rPr lang="en-US" smtClean="0"/>
-              <a:t>5/14/2024</a:t>
+              <a:t>6/18/2024</a:t>
             </a:fld>
             <a:endParaRPr lang="en-US"/>
           </a:p>
@@ -2117,7 +2117,7 @@
           <a:p>
             <a:fld id="{C9619C31-9712-4FF2-9651-92B20A921DDE}" type="datetimeFigureOut">
               <a:rPr lang="en-US" smtClean="0"/>
-              <a:t>5/14/2024</a:t>
+              <a:t>6/18/2024</a:t>
             </a:fld>
             <a:endParaRPr lang="en-US"/>
           </a:p>
@@ -2428,7 +2428,7 @@
           <a:p>
             <a:fld id="{C9619C31-9712-4FF2-9651-92B20A921DDE}" type="datetimeFigureOut">
               <a:rPr lang="en-US" smtClean="0"/>
-              <a:t>5/14/2024</a:t>
+              <a:t>6/18/2024</a:t>
             </a:fld>
             <a:endParaRPr lang="en-US"/>
           </a:p>
@@ -2716,7 +2716,7 @@
           <a:p>
             <a:fld id="{C9619C31-9712-4FF2-9651-92B20A921DDE}" type="datetimeFigureOut">
               <a:rPr lang="en-US" smtClean="0"/>
-              <a:t>5/14/2024</a:t>
+              <a:t>6/18/2024</a:t>
             </a:fld>
             <a:endParaRPr lang="en-US"/>
           </a:p>
@@ -2957,7 +2957,7 @@
           <a:p>
             <a:fld id="{C9619C31-9712-4FF2-9651-92B20A921DDE}" type="datetimeFigureOut">
               <a:rPr lang="en-US" smtClean="0"/>
-              <a:t>5/14/2024</a:t>
+              <a:t>6/18/2024</a:t>
             </a:fld>
             <a:endParaRPr lang="en-US"/>
           </a:p>
@@ -5678,7 +5678,7 @@
           <a:p>
             <a:r>
               <a:rPr lang="en-US" dirty="0"/>
-              <a:t>Lexical data owned in the </a:t>
+              <a:t>Lexical data is owned in the </a:t>
             </a:r>
             <a:r>
               <a:rPr lang="en-US" dirty="0" err="1"/>
@@ -6881,6 +6881,36 @@
           </a:prstGeom>
         </p:spPr>
       </p:pic>
+      <p:pic>
+        <p:nvPicPr>
+          <p:cNvPr id="4" name="Picture 3">
+            <a:extLst>
+              <a:ext uri="{FF2B5EF4-FFF2-40B4-BE49-F238E27FC236}">
+                <a16:creationId xmlns:a16="http://schemas.microsoft.com/office/drawing/2014/main" id="{4A08103D-8E96-4500-92C7-7B03B7E826B3}"/>
+              </a:ext>
+            </a:extLst>
+          </p:cNvPr>
+          <p:cNvPicPr>
+            <a:picLocks noChangeAspect="1"/>
+          </p:cNvPicPr>
+          <p:nvPr/>
+        </p:nvPicPr>
+        <p:blipFill>
+          <a:blip r:embed="rId3"/>
+          <a:stretch>
+            <a:fillRect/>
+          </a:stretch>
+        </p:blipFill>
+        <p:spPr>
+          <a:xfrm>
+            <a:off x="6606509" y="1048656"/>
+            <a:ext cx="4899692" cy="842482"/>
+          </a:xfrm>
+          <a:prstGeom prst="rect">
+            <a:avLst/>
+          </a:prstGeom>
+        </p:spPr>
+      </p:pic>
     </p:spTree>
     <p:extLst>
       <p:ext uri="{BB962C8B-B14F-4D97-AF65-F5344CB8AC3E}">
@@ -7663,7 +7693,7 @@
           <a:p>
             <a:r>
               <a:rPr lang="en-US" dirty="0"/>
-              <a:t>Styles for each field and Before, Between, and After text is controlled via configuration</a:t>
+              <a:t>Styles for each field and Before, Between, and After text is controlled via configuration.</a:t>
             </a:r>
           </a:p>
           <a:p>
@@ -7706,10 +7736,10 @@
       </p:sp>
       <p:pic>
         <p:nvPicPr>
-          <p:cNvPr id="4" name="Picture 3">
-            <a:extLst>
-              <a:ext uri="{FF2B5EF4-FFF2-40B4-BE49-F238E27FC236}">
-                <a16:creationId xmlns:a16="http://schemas.microsoft.com/office/drawing/2014/main" id="{173B44D3-8485-4667-89A7-340C988E6136}"/>
+          <p:cNvPr id="5" name="Picture 4">
+            <a:extLst>
+              <a:ext uri="{FF2B5EF4-FFF2-40B4-BE49-F238E27FC236}">
+                <a16:creationId xmlns:a16="http://schemas.microsoft.com/office/drawing/2014/main" id="{CB84722D-E0CD-414E-A460-43F937D7A62B}"/>
               </a:ext>
             </a:extLst>
           </p:cNvPr>
@@ -7726,8 +7756,8 @@
         </p:blipFill>
         <p:spPr>
           <a:xfrm>
-            <a:off x="6096000" y="538162"/>
-            <a:ext cx="4715533" cy="4324954"/>
+            <a:off x="6425035" y="265244"/>
+            <a:ext cx="4667508" cy="4210380"/>
           </a:xfrm>
           <a:prstGeom prst="rect">
             <a:avLst/>
@@ -7967,7 +7997,7 @@
             </a:r>
             <a:r>
               <a:rPr lang="en-US" dirty="0"/>
-              <a:t> is the class for lexical entries. This class is used for main entries that show as headwords in the dictionary, and also for entries that are variants or complex forms of the main entries.</a:t>
+              <a:t> is the class for lexical entries. This class is used for main entries that show as headwords in the dictionary, and also for entries that are variants or complex forms (e.g., subentries) of the main entries.</a:t>
             </a:r>
           </a:p>
           <a:p>
@@ -8034,7 +8064,7 @@
         </p:blipFill>
         <p:spPr>
           <a:xfrm>
-            <a:off x="2248292" y="3699645"/>
+            <a:off x="2248292" y="4047989"/>
             <a:ext cx="5586146" cy="2657612"/>
           </a:xfrm>
           <a:prstGeom prst="rect">
@@ -10322,7 +10352,7 @@
         </p:spPr>
         <p:txBody>
           <a:bodyPr>
-            <a:normAutofit fontScale="77500" lnSpcReduction="20000"/>
+            <a:normAutofit fontScale="85000" lnSpcReduction="20000"/>
           </a:bodyPr>
           <a:lstStyle/>
           <a:p>
@@ -11879,8 +11909,8 @@
         </p:blipFill>
         <p:spPr>
           <a:xfrm>
-            <a:off x="1366048" y="4752188"/>
-            <a:ext cx="6943065" cy="1892597"/>
+            <a:off x="1627305" y="5002560"/>
+            <a:ext cx="6591409" cy="1796740"/>
           </a:xfrm>
           <a:prstGeom prst="rect">
             <a:avLst/>
@@ -12359,7 +12389,7 @@
         </p:spPr>
         <p:txBody>
           <a:bodyPr>
-            <a:normAutofit lnSpcReduction="10000"/>
+            <a:normAutofit fontScale="92500" lnSpcReduction="20000"/>
           </a:bodyPr>
           <a:lstStyle/>
           <a:p>
@@ -12393,9 +12423,15 @@
             <a:endParaRPr lang="en-US" dirty="0"/>
           </a:p>
           <a:p>
-            <a:r>
-              <a:rPr lang="en-US" dirty="0"/>
-              <a:t>All of the strings in these examples are MultiUnicode, so they can have any number of vernacular writing systems. Most strings in </a:t>
+            <a:endParaRPr lang="en-US" dirty="0"/>
+          </a:p>
+          <a:p>
+            <a:endParaRPr lang="en-US" dirty="0"/>
+          </a:p>
+          <a:p>
+            <a:r>
+              <a:rPr lang="en-US" dirty="0"/>
+              <a:t>All of the strings in these examples are MultiUnicode, so they can have any number of vernacular or analysis writing systems. Most strings in </a:t>
             </a:r>
             <a:r>
               <a:rPr lang="en-US" dirty="0" err="1"/>
@@ -12875,7 +12911,7 @@
           <a:p>
             <a:r>
               <a:rPr lang="en-US" dirty="0"/>
-              <a:t>It’s not possible to create an entry without a lexeme form. This is because the </a:t>
+              <a:t>It’s not possible to create an entry in the FLEx UI without a lexeme form. This is because the </a:t>
             </a:r>
             <a:r>
               <a:rPr lang="en-US" dirty="0" err="1"/>

</xml_diff>

<commit_message>
June 20 updates to technical docs
Update to docx and pptx files.

Change-Id: I3b64d233d4779afd7f2ccbdc7b86c56f79da488b
</commit_message>
<xml_diff>
--- a/HelpResourcesSources/TechnicalNotes/FLEx 9.1 Conceptual Model - Lexicon model.pptx
+++ b/HelpResourcesSources/TechnicalNotes/FLEx 9.1 Conceptual Model - Lexicon model.pptx
@@ -307,7 +307,7 @@
           <a:p>
             <a:fld id="{C9619C31-9712-4FF2-9651-92B20A921DDE}" type="datetimeFigureOut">
               <a:rPr lang="en-US" smtClean="0"/>
-              <a:t>6/18/2024</a:t>
+              <a:t>6/20/2024</a:t>
             </a:fld>
             <a:endParaRPr lang="en-US"/>
           </a:p>
@@ -505,7 +505,7 @@
           <a:p>
             <a:fld id="{C9619C31-9712-4FF2-9651-92B20A921DDE}" type="datetimeFigureOut">
               <a:rPr lang="en-US" smtClean="0"/>
-              <a:t>6/18/2024</a:t>
+              <a:t>6/20/2024</a:t>
             </a:fld>
             <a:endParaRPr lang="en-US"/>
           </a:p>
@@ -713,7 +713,7 @@
           <a:p>
             <a:fld id="{C9619C31-9712-4FF2-9651-92B20A921DDE}" type="datetimeFigureOut">
               <a:rPr lang="en-US" smtClean="0"/>
-              <a:t>6/18/2024</a:t>
+              <a:t>6/20/2024</a:t>
             </a:fld>
             <a:endParaRPr lang="en-US"/>
           </a:p>
@@ -911,7 +911,7 @@
           <a:p>
             <a:fld id="{C9619C31-9712-4FF2-9651-92B20A921DDE}" type="datetimeFigureOut">
               <a:rPr lang="en-US" smtClean="0"/>
-              <a:t>6/18/2024</a:t>
+              <a:t>6/20/2024</a:t>
             </a:fld>
             <a:endParaRPr lang="en-US"/>
           </a:p>
@@ -1186,7 +1186,7 @@
           <a:p>
             <a:fld id="{C9619C31-9712-4FF2-9651-92B20A921DDE}" type="datetimeFigureOut">
               <a:rPr lang="en-US" smtClean="0"/>
-              <a:t>6/18/2024</a:t>
+              <a:t>6/20/2024</a:t>
             </a:fld>
             <a:endParaRPr lang="en-US"/>
           </a:p>
@@ -1451,7 +1451,7 @@
           <a:p>
             <a:fld id="{C9619C31-9712-4FF2-9651-92B20A921DDE}" type="datetimeFigureOut">
               <a:rPr lang="en-US" smtClean="0"/>
-              <a:t>6/18/2024</a:t>
+              <a:t>6/20/2024</a:t>
             </a:fld>
             <a:endParaRPr lang="en-US"/>
           </a:p>
@@ -1863,7 +1863,7 @@
           <a:p>
             <a:fld id="{C9619C31-9712-4FF2-9651-92B20A921DDE}" type="datetimeFigureOut">
               <a:rPr lang="en-US" smtClean="0"/>
-              <a:t>6/18/2024</a:t>
+              <a:t>6/20/2024</a:t>
             </a:fld>
             <a:endParaRPr lang="en-US"/>
           </a:p>
@@ -2004,7 +2004,7 @@
           <a:p>
             <a:fld id="{C9619C31-9712-4FF2-9651-92B20A921DDE}" type="datetimeFigureOut">
               <a:rPr lang="en-US" smtClean="0"/>
-              <a:t>6/18/2024</a:t>
+              <a:t>6/20/2024</a:t>
             </a:fld>
             <a:endParaRPr lang="en-US"/>
           </a:p>
@@ -2117,7 +2117,7 @@
           <a:p>
             <a:fld id="{C9619C31-9712-4FF2-9651-92B20A921DDE}" type="datetimeFigureOut">
               <a:rPr lang="en-US" smtClean="0"/>
-              <a:t>6/18/2024</a:t>
+              <a:t>6/20/2024</a:t>
             </a:fld>
             <a:endParaRPr lang="en-US"/>
           </a:p>
@@ -2428,7 +2428,7 @@
           <a:p>
             <a:fld id="{C9619C31-9712-4FF2-9651-92B20A921DDE}" type="datetimeFigureOut">
               <a:rPr lang="en-US" smtClean="0"/>
-              <a:t>6/18/2024</a:t>
+              <a:t>6/20/2024</a:t>
             </a:fld>
             <a:endParaRPr lang="en-US"/>
           </a:p>
@@ -2716,7 +2716,7 @@
           <a:p>
             <a:fld id="{C9619C31-9712-4FF2-9651-92B20A921DDE}" type="datetimeFigureOut">
               <a:rPr lang="en-US" smtClean="0"/>
-              <a:t>6/18/2024</a:t>
+              <a:t>6/20/2024</a:t>
             </a:fld>
             <a:endParaRPr lang="en-US"/>
           </a:p>
@@ -2957,7 +2957,7 @@
           <a:p>
             <a:fld id="{C9619C31-9712-4FF2-9651-92B20A921DDE}" type="datetimeFigureOut">
               <a:rPr lang="en-US" smtClean="0"/>
-              <a:t>6/18/2024</a:t>
+              <a:t>6/20/2024</a:t>
             </a:fld>
             <a:endParaRPr lang="en-US"/>
           </a:p>
@@ -3717,6 +3717,16 @@
           </a:p>
           <a:p>
             <a:r>
+              <a:rPr lang="en-US" dirty="0" err="1"/>
+              <a:t>SecondaryOrder</a:t>
+            </a:r>
+            <a:r>
+              <a:rPr lang="en-US" dirty="0"/>
+              <a:t> allows you to order affixes by type, and uses a different homograph number.</a:t>
+            </a:r>
+          </a:p>
+          <a:p>
+            <a:r>
               <a:rPr lang="en-US" dirty="0"/>
               <a:t>You can force renumbering homographs in FLEx using Tools &gt; Utilities &gt; Reassign Homographs.</a:t>
             </a:r>
@@ -5716,7 +5726,15 @@
             </a:r>
             <a:r>
               <a:rPr lang="en-US" dirty="0"/>
-              <a:t> via a virtual Entries method.</a:t>
+              <a:t> via a virtual Entries method, or through the </a:t>
+            </a:r>
+            <a:r>
+              <a:rPr lang="en-US" dirty="0" err="1"/>
+              <a:t>ILexEntry</a:t>
+            </a:r>
+            <a:r>
+              <a:rPr lang="en-US" dirty="0"/>
+              <a:t> repository.</a:t>
             </a:r>
           </a:p>
           <a:p>
@@ -6531,7 +6549,7 @@
             </a:r>
             <a:r>
               <a:rPr lang="en-US" dirty="0"/>
-              <a:t> file. Data can be removed manually in the file, or the file can be deleted at any time to remove all Message.</a:t>
+              <a:t> file. Data can be removed manually in the file, or the file can be deleted at any time to remove all Messages.</a:t>
             </a:r>
           </a:p>
           <a:p>
@@ -8233,7 +8251,7 @@
         </p:blipFill>
         <p:spPr>
           <a:xfrm>
-            <a:off x="1384526" y="4108355"/>
+            <a:off x="1498116" y="4109884"/>
             <a:ext cx="7234511" cy="2137834"/>
           </a:xfrm>
           <a:prstGeom prst="rect">
@@ -9846,15 +9864,7 @@
             </a:r>
             <a:r>
               <a:rPr lang="en-US" dirty="0"/>
-              <a:t> is actually abstract as well as </a:t>
-            </a:r>
-            <a:r>
-              <a:rPr lang="en-US" dirty="0" err="1"/>
-              <a:t>MoAffixForm</a:t>
-            </a:r>
-            <a:r>
-              <a:rPr lang="en-US" dirty="0"/>
-              <a:t>, so there are only 3 choices to use.</a:t>
+              <a:t> is actually abstract, so there are only 3 choices to use.</a:t>
             </a:r>
           </a:p>
           <a:p>
@@ -12018,15 +12028,7 @@
             </a:r>
             <a:r>
               <a:rPr lang="en-US" dirty="0"/>
-              <a:t>, if it owns </a:t>
-            </a:r>
-            <a:r>
-              <a:rPr lang="en-US"/>
-              <a:t>a sense, </a:t>
-            </a:r>
-            <a:r>
-              <a:rPr lang="en-US" dirty="0"/>
-              <a:t>is owning at least one </a:t>
+              <a:t>, if it owns a sense, is owning at least one </a:t>
             </a:r>
             <a:r>
               <a:rPr lang="en-US" dirty="0" err="1"/>
@@ -12108,7 +12110,7 @@
             </a:r>
             <a:r>
               <a:rPr lang="en-US" dirty="0"/>
-              <a:t> objects will be added to the entry so they can be referenced by the senses.</a:t>
+              <a:t> objects will be added to the entry so they can be referenced by the senses. These items are removed when senses that use them are deleted.</a:t>
             </a:r>
           </a:p>
           <a:p>

</xml_diff>

<commit_message>
Conceptual model updates for June 24
.pptx, .docx, .odg updates.

Change-Id: I39e7bc0ab3e8339c7cc4ab3ad1ae0eeb784af22c
</commit_message>
<xml_diff>
--- a/HelpResourcesSources/TechnicalNotes/FLEx 9.1 Conceptual Model - Lexicon model.pptx
+++ b/HelpResourcesSources/TechnicalNotes/FLEx 9.1 Conceptual Model - Lexicon model.pptx
@@ -54,6 +54,7 @@
     <p:sldId id="305" r:id="rId48"/>
     <p:sldId id="306" r:id="rId49"/>
     <p:sldId id="307" r:id="rId50"/>
+    <p:sldId id="309" r:id="rId51"/>
   </p:sldIdLst>
   <p:sldSz cx="12192000" cy="6858000"/>
   <p:notesSz cx="6858000" cy="9144000"/>
@@ -307,7 +308,7 @@
           <a:p>
             <a:fld id="{C9619C31-9712-4FF2-9651-92B20A921DDE}" type="datetimeFigureOut">
               <a:rPr lang="en-US" smtClean="0"/>
-              <a:t>6/20/2024</a:t>
+              <a:t>6/21/2024</a:t>
             </a:fld>
             <a:endParaRPr lang="en-US"/>
           </a:p>
@@ -505,7 +506,7 @@
           <a:p>
             <a:fld id="{C9619C31-9712-4FF2-9651-92B20A921DDE}" type="datetimeFigureOut">
               <a:rPr lang="en-US" smtClean="0"/>
-              <a:t>6/20/2024</a:t>
+              <a:t>6/21/2024</a:t>
             </a:fld>
             <a:endParaRPr lang="en-US"/>
           </a:p>
@@ -713,7 +714,7 @@
           <a:p>
             <a:fld id="{C9619C31-9712-4FF2-9651-92B20A921DDE}" type="datetimeFigureOut">
               <a:rPr lang="en-US" smtClean="0"/>
-              <a:t>6/20/2024</a:t>
+              <a:t>6/21/2024</a:t>
             </a:fld>
             <a:endParaRPr lang="en-US"/>
           </a:p>
@@ -911,7 +912,7 @@
           <a:p>
             <a:fld id="{C9619C31-9712-4FF2-9651-92B20A921DDE}" type="datetimeFigureOut">
               <a:rPr lang="en-US" smtClean="0"/>
-              <a:t>6/20/2024</a:t>
+              <a:t>6/21/2024</a:t>
             </a:fld>
             <a:endParaRPr lang="en-US"/>
           </a:p>
@@ -1186,7 +1187,7 @@
           <a:p>
             <a:fld id="{C9619C31-9712-4FF2-9651-92B20A921DDE}" type="datetimeFigureOut">
               <a:rPr lang="en-US" smtClean="0"/>
-              <a:t>6/20/2024</a:t>
+              <a:t>6/21/2024</a:t>
             </a:fld>
             <a:endParaRPr lang="en-US"/>
           </a:p>
@@ -1451,7 +1452,7 @@
           <a:p>
             <a:fld id="{C9619C31-9712-4FF2-9651-92B20A921DDE}" type="datetimeFigureOut">
               <a:rPr lang="en-US" smtClean="0"/>
-              <a:t>6/20/2024</a:t>
+              <a:t>6/21/2024</a:t>
             </a:fld>
             <a:endParaRPr lang="en-US"/>
           </a:p>
@@ -1863,7 +1864,7 @@
           <a:p>
             <a:fld id="{C9619C31-9712-4FF2-9651-92B20A921DDE}" type="datetimeFigureOut">
               <a:rPr lang="en-US" smtClean="0"/>
-              <a:t>6/20/2024</a:t>
+              <a:t>6/21/2024</a:t>
             </a:fld>
             <a:endParaRPr lang="en-US"/>
           </a:p>
@@ -2004,7 +2005,7 @@
           <a:p>
             <a:fld id="{C9619C31-9712-4FF2-9651-92B20A921DDE}" type="datetimeFigureOut">
               <a:rPr lang="en-US" smtClean="0"/>
-              <a:t>6/20/2024</a:t>
+              <a:t>6/21/2024</a:t>
             </a:fld>
             <a:endParaRPr lang="en-US"/>
           </a:p>
@@ -2117,7 +2118,7 @@
           <a:p>
             <a:fld id="{C9619C31-9712-4FF2-9651-92B20A921DDE}" type="datetimeFigureOut">
               <a:rPr lang="en-US" smtClean="0"/>
-              <a:t>6/20/2024</a:t>
+              <a:t>6/21/2024</a:t>
             </a:fld>
             <a:endParaRPr lang="en-US"/>
           </a:p>
@@ -2428,7 +2429,7 @@
           <a:p>
             <a:fld id="{C9619C31-9712-4FF2-9651-92B20A921DDE}" type="datetimeFigureOut">
               <a:rPr lang="en-US" smtClean="0"/>
-              <a:t>6/20/2024</a:t>
+              <a:t>6/21/2024</a:t>
             </a:fld>
             <a:endParaRPr lang="en-US"/>
           </a:p>
@@ -2716,7 +2717,7 @@
           <a:p>
             <a:fld id="{C9619C31-9712-4FF2-9651-92B20A921DDE}" type="datetimeFigureOut">
               <a:rPr lang="en-US" smtClean="0"/>
-              <a:t>6/20/2024</a:t>
+              <a:t>6/21/2024</a:t>
             </a:fld>
             <a:endParaRPr lang="en-US"/>
           </a:p>
@@ -2957,7 +2958,7 @@
           <a:p>
             <a:fld id="{C9619C31-9712-4FF2-9651-92B20A921DDE}" type="datetimeFigureOut">
               <a:rPr lang="en-US" smtClean="0"/>
-              <a:t>6/20/2024</a:t>
+              <a:t>6/21/2024</a:t>
             </a:fld>
             <a:endParaRPr lang="en-US"/>
           </a:p>
@@ -4186,10 +4187,10 @@
       </p:sp>
       <p:pic>
         <p:nvPicPr>
-          <p:cNvPr id="4" name="Picture 3">
-            <a:extLst>
-              <a:ext uri="{FF2B5EF4-FFF2-40B4-BE49-F238E27FC236}">
-                <a16:creationId xmlns:a16="http://schemas.microsoft.com/office/drawing/2014/main" id="{E973EBF4-10A3-408F-8A9E-CC82851DC41C}"/>
+          <p:cNvPr id="6" name="Picture 5">
+            <a:extLst>
+              <a:ext uri="{FF2B5EF4-FFF2-40B4-BE49-F238E27FC236}">
+                <a16:creationId xmlns:a16="http://schemas.microsoft.com/office/drawing/2014/main" id="{825954C7-6C3C-402F-A692-1E030F7F8F0F}"/>
               </a:ext>
             </a:extLst>
           </p:cNvPr>
@@ -4206,8 +4207,8 @@
         </p:blipFill>
         <p:spPr>
           <a:xfrm>
-            <a:off x="2666457" y="1361267"/>
-            <a:ext cx="7718515" cy="3651160"/>
+            <a:off x="2754085" y="1600720"/>
+            <a:ext cx="6925898" cy="3207066"/>
           </a:xfrm>
           <a:prstGeom prst="rect">
             <a:avLst/>
@@ -10362,7 +10363,7 @@
         </p:spPr>
         <p:txBody>
           <a:bodyPr>
-            <a:normAutofit fontScale="85000" lnSpcReduction="20000"/>
+            <a:normAutofit fontScale="77500" lnSpcReduction="20000"/>
           </a:bodyPr>
           <a:lstStyle/>
           <a:p>
@@ -12171,6 +12172,121 @@
     <p:extLst>
       <p:ext uri="{BB962C8B-B14F-4D97-AF65-F5344CB8AC3E}">
         <p14:creationId xmlns:p14="http://schemas.microsoft.com/office/powerpoint/2010/main" val="3680507329"/>
+      </p:ext>
+    </p:extLst>
+  </p:cSld>
+  <p:clrMapOvr>
+    <a:masterClrMapping/>
+  </p:clrMapOvr>
+</p:sld>
+</file>
+
+<file path=ppt/slides/slide50.xml><?xml version="1.0" encoding="utf-8"?>
+<p:sld xmlns:a="http://schemas.openxmlformats.org/drawingml/2006/main" xmlns:r="http://schemas.openxmlformats.org/officeDocument/2006/relationships" xmlns:p="http://schemas.openxmlformats.org/presentationml/2006/main">
+  <p:cSld>
+    <p:spTree>
+      <p:nvGrpSpPr>
+        <p:cNvPr id="1" name=""/>
+        <p:cNvGrpSpPr/>
+        <p:nvPr/>
+      </p:nvGrpSpPr>
+      <p:grpSpPr>
+        <a:xfrm>
+          <a:off x="0" y="0"/>
+          <a:ext cx="0" cy="0"/>
+          <a:chOff x="0" y="0"/>
+          <a:chExt cx="0" cy="0"/>
+        </a:xfrm>
+      </p:grpSpPr>
+      <p:sp>
+        <p:nvSpPr>
+          <p:cNvPr id="2" name="Title 1">
+            <a:extLst>
+              <a:ext uri="{FF2B5EF4-FFF2-40B4-BE49-F238E27FC236}">
+                <a16:creationId xmlns:a16="http://schemas.microsoft.com/office/drawing/2014/main" id="{70B9F0AF-55E3-4EFA-AF6E-657FB15003F1}"/>
+              </a:ext>
+            </a:extLst>
+          </p:cNvPr>
+          <p:cNvSpPr>
+            <a:spLocks noGrp="1"/>
+          </p:cNvSpPr>
+          <p:nvPr>
+            <p:ph type="title"/>
+          </p:nvPr>
+        </p:nvSpPr>
+        <p:spPr/>
+        <p:txBody>
+          <a:bodyPr/>
+          <a:lstStyle/>
+          <a:p>
+            <a:r>
+              <a:rPr lang="en-US" dirty="0"/>
+              <a:t>Documentation</a:t>
+            </a:r>
+          </a:p>
+        </p:txBody>
+      </p:sp>
+      <p:sp>
+        <p:nvSpPr>
+          <p:cNvPr id="3" name="Content Placeholder 2">
+            <a:extLst>
+              <a:ext uri="{FF2B5EF4-FFF2-40B4-BE49-F238E27FC236}">
+                <a16:creationId xmlns:a16="http://schemas.microsoft.com/office/drawing/2014/main" id="{D09C55A4-3E56-4F9F-A12B-15F5F796694C}"/>
+              </a:ext>
+            </a:extLst>
+          </p:cNvPr>
+          <p:cNvSpPr>
+            <a:spLocks noGrp="1"/>
+          </p:cNvSpPr>
+          <p:nvPr>
+            <p:ph idx="1"/>
+          </p:nvPr>
+        </p:nvSpPr>
+        <p:spPr/>
+        <p:txBody>
+          <a:bodyPr/>
+          <a:lstStyle/>
+          <a:p>
+            <a:r>
+              <a:rPr lang="en-US" dirty="0"/>
+              <a:t>FLEx 9.1 Conceptual Model documentation covered in these webinars is available as “FLEx 9.1 Conceptual model.pdf”</a:t>
+            </a:r>
+            <a:br>
+              <a:rPr lang="en-US" dirty="0"/>
+            </a:br>
+            <a:r>
+              <a:rPr lang="en-US" dirty="0"/>
+              <a:t>in software.sil.org/fieldworks/support/technical-documents</a:t>
+            </a:r>
+            <a:br>
+              <a:rPr lang="en-US" dirty="0"/>
+            </a:br>
+            <a:r>
+              <a:rPr lang="en-US" dirty="0">
+                <a:hlinkClick r:id="rId2"/>
+              </a:rPr>
+              <a:t>https://downloads.languagetechnology.org/fieldworks/Documentation/FLEx%209.1%20Conceptual%20Model.pdf</a:t>
+            </a:r>
+            <a:r>
+              <a:rPr lang="en-US" dirty="0"/>
+              <a:t> (The file also has a link to a Flex 9.1 sample project used in this document, as well as the three PowerPoint presentations.)</a:t>
+            </a:r>
+          </a:p>
+          <a:p>
+            <a:endParaRPr lang="en-US"/>
+          </a:p>
+          <a:p>
+            <a:pPr marL="0" indent="0">
+              <a:buNone/>
+            </a:pPr>
+            <a:endParaRPr lang="en-US"/>
+          </a:p>
+        </p:txBody>
+      </p:sp>
+    </p:spTree>
+    <p:extLst>
+      <p:ext uri="{BB962C8B-B14F-4D97-AF65-F5344CB8AC3E}">
+        <p14:creationId xmlns:p14="http://schemas.microsoft.com/office/powerpoint/2010/main" val="550192045"/>
       </p:ext>
     </p:extLst>
   </p:cSld>

</xml_diff>

<commit_message>
Update to Flex9.1 documents
Made corrections two two diagrams and some associated text in docx,
odg, and pptx files

Change-Id: Ie55b456becd15b01f92032a985b912681859d03e
</commit_message>
<xml_diff>
--- a/HelpResourcesSources/TechnicalNotes/FLEx 9.1 Conceptual Model - Lexicon model.pptx
+++ b/HelpResourcesSources/TechnicalNotes/FLEx 9.1 Conceptual Model - Lexicon model.pptx
@@ -308,7 +308,7 @@
           <a:p>
             <a:fld id="{C9619C31-9712-4FF2-9651-92B20A921DDE}" type="datetimeFigureOut">
               <a:rPr lang="en-US" smtClean="0"/>
-              <a:t>6/25/2024</a:t>
+              <a:t>7/19/2024</a:t>
             </a:fld>
             <a:endParaRPr lang="en-US"/>
           </a:p>
@@ -506,7 +506,7 @@
           <a:p>
             <a:fld id="{C9619C31-9712-4FF2-9651-92B20A921DDE}" type="datetimeFigureOut">
               <a:rPr lang="en-US" smtClean="0"/>
-              <a:t>6/25/2024</a:t>
+              <a:t>7/19/2024</a:t>
             </a:fld>
             <a:endParaRPr lang="en-US"/>
           </a:p>
@@ -714,7 +714,7 @@
           <a:p>
             <a:fld id="{C9619C31-9712-4FF2-9651-92B20A921DDE}" type="datetimeFigureOut">
               <a:rPr lang="en-US" smtClean="0"/>
-              <a:t>6/25/2024</a:t>
+              <a:t>7/19/2024</a:t>
             </a:fld>
             <a:endParaRPr lang="en-US"/>
           </a:p>
@@ -912,7 +912,7 @@
           <a:p>
             <a:fld id="{C9619C31-9712-4FF2-9651-92B20A921DDE}" type="datetimeFigureOut">
               <a:rPr lang="en-US" smtClean="0"/>
-              <a:t>6/25/2024</a:t>
+              <a:t>7/19/2024</a:t>
             </a:fld>
             <a:endParaRPr lang="en-US"/>
           </a:p>
@@ -1187,7 +1187,7 @@
           <a:p>
             <a:fld id="{C9619C31-9712-4FF2-9651-92B20A921DDE}" type="datetimeFigureOut">
               <a:rPr lang="en-US" smtClean="0"/>
-              <a:t>6/25/2024</a:t>
+              <a:t>7/19/2024</a:t>
             </a:fld>
             <a:endParaRPr lang="en-US"/>
           </a:p>
@@ -1452,7 +1452,7 @@
           <a:p>
             <a:fld id="{C9619C31-9712-4FF2-9651-92B20A921DDE}" type="datetimeFigureOut">
               <a:rPr lang="en-US" smtClean="0"/>
-              <a:t>6/25/2024</a:t>
+              <a:t>7/19/2024</a:t>
             </a:fld>
             <a:endParaRPr lang="en-US"/>
           </a:p>
@@ -1864,7 +1864,7 @@
           <a:p>
             <a:fld id="{C9619C31-9712-4FF2-9651-92B20A921DDE}" type="datetimeFigureOut">
               <a:rPr lang="en-US" smtClean="0"/>
-              <a:t>6/25/2024</a:t>
+              <a:t>7/19/2024</a:t>
             </a:fld>
             <a:endParaRPr lang="en-US"/>
           </a:p>
@@ -2005,7 +2005,7 @@
           <a:p>
             <a:fld id="{C9619C31-9712-4FF2-9651-92B20A921DDE}" type="datetimeFigureOut">
               <a:rPr lang="en-US" smtClean="0"/>
-              <a:t>6/25/2024</a:t>
+              <a:t>7/19/2024</a:t>
             </a:fld>
             <a:endParaRPr lang="en-US"/>
           </a:p>
@@ -2118,7 +2118,7 @@
           <a:p>
             <a:fld id="{C9619C31-9712-4FF2-9651-92B20A921DDE}" type="datetimeFigureOut">
               <a:rPr lang="en-US" smtClean="0"/>
-              <a:t>6/25/2024</a:t>
+              <a:t>7/19/2024</a:t>
             </a:fld>
             <a:endParaRPr lang="en-US"/>
           </a:p>
@@ -2429,7 +2429,7 @@
           <a:p>
             <a:fld id="{C9619C31-9712-4FF2-9651-92B20A921DDE}" type="datetimeFigureOut">
               <a:rPr lang="en-US" smtClean="0"/>
-              <a:t>6/25/2024</a:t>
+              <a:t>7/19/2024</a:t>
             </a:fld>
             <a:endParaRPr lang="en-US"/>
           </a:p>
@@ -2717,7 +2717,7 @@
           <a:p>
             <a:fld id="{C9619C31-9712-4FF2-9651-92B20A921DDE}" type="datetimeFigureOut">
               <a:rPr lang="en-US" smtClean="0"/>
-              <a:t>6/25/2024</a:t>
+              <a:t>7/19/2024</a:t>
             </a:fld>
             <a:endParaRPr lang="en-US"/>
           </a:p>
@@ -2958,7 +2958,7 @@
           <a:p>
             <a:fld id="{C9619C31-9712-4FF2-9651-92B20A921DDE}" type="datetimeFigureOut">
               <a:rPr lang="en-US" smtClean="0"/>
-              <a:t>6/25/2024</a:t>
+              <a:t>7/19/2024</a:t>
             </a:fld>
             <a:endParaRPr lang="en-US"/>
           </a:p>
@@ -4739,7 +4739,15 @@
             </a:r>
             <a:r>
               <a:rPr lang="en-US" dirty="0"/>
-              <a:t> objects owned in the </a:t>
+              <a:t> objects owned in the Phonemes property of </a:t>
+            </a:r>
+            <a:r>
+              <a:rPr lang="en-US" dirty="0" err="1"/>
+              <a:t>PhPhonemeSet</a:t>
+            </a:r>
+            <a:r>
+              <a:rPr lang="en-US" dirty="0"/>
+              <a:t>, owned in the </a:t>
             </a:r>
             <a:r>
               <a:rPr lang="en-US" dirty="0" err="1"/>
@@ -4842,10 +4850,10 @@
       </p:pic>
       <p:pic>
         <p:nvPicPr>
-          <p:cNvPr id="7" name="Picture 6">
-            <a:extLst>
-              <a:ext uri="{FF2B5EF4-FFF2-40B4-BE49-F238E27FC236}">
-                <a16:creationId xmlns:a16="http://schemas.microsoft.com/office/drawing/2014/main" id="{84E7A88A-60D9-40ED-BBCA-4E8041B71D25}"/>
+          <p:cNvPr id="4" name="Picture 3">
+            <a:extLst>
+              <a:ext uri="{FF2B5EF4-FFF2-40B4-BE49-F238E27FC236}">
+                <a16:creationId xmlns:a16="http://schemas.microsoft.com/office/drawing/2014/main" id="{E3F194E6-4710-467F-A702-A5C22C7ACBED}"/>
               </a:ext>
             </a:extLst>
           </p:cNvPr>
@@ -4862,8 +4870,8 @@
         </p:blipFill>
         <p:spPr>
           <a:xfrm>
-            <a:off x="6902998" y="2476367"/>
-            <a:ext cx="4601217" cy="952633"/>
+            <a:off x="6488746" y="3276600"/>
+            <a:ext cx="5167773" cy="890995"/>
           </a:xfrm>
           <a:prstGeom prst="rect">
             <a:avLst/>
@@ -5425,10 +5433,10 @@
       </p:sp>
       <p:pic>
         <p:nvPicPr>
-          <p:cNvPr id="4" name="Picture 3">
-            <a:extLst>
-              <a:ext uri="{FF2B5EF4-FFF2-40B4-BE49-F238E27FC236}">
-                <a16:creationId xmlns:a16="http://schemas.microsoft.com/office/drawing/2014/main" id="{1DC238F5-D35E-4EEC-8014-911B36B296DA}"/>
+          <p:cNvPr id="5" name="Picture 4">
+            <a:extLst>
+              <a:ext uri="{FF2B5EF4-FFF2-40B4-BE49-F238E27FC236}">
+                <a16:creationId xmlns:a16="http://schemas.microsoft.com/office/drawing/2014/main" id="{E7789944-9765-4680-84F0-323941B2B145}"/>
               </a:ext>
             </a:extLst>
           </p:cNvPr>
@@ -5445,8 +5453,8 @@
         </p:blipFill>
         <p:spPr>
           <a:xfrm>
-            <a:off x="3942500" y="839258"/>
-            <a:ext cx="7695110" cy="5781675"/>
+            <a:off x="838200" y="3429000"/>
+            <a:ext cx="2630238" cy="1381539"/>
           </a:xfrm>
           <a:prstGeom prst="rect">
             <a:avLst/>
@@ -5455,10 +5463,10 @@
       </p:pic>
       <p:pic>
         <p:nvPicPr>
-          <p:cNvPr id="5" name="Picture 4">
-            <a:extLst>
-              <a:ext uri="{FF2B5EF4-FFF2-40B4-BE49-F238E27FC236}">
-                <a16:creationId xmlns:a16="http://schemas.microsoft.com/office/drawing/2014/main" id="{E7789944-9765-4680-84F0-323941B2B145}"/>
+          <p:cNvPr id="6" name="Picture 5">
+            <a:extLst>
+              <a:ext uri="{FF2B5EF4-FFF2-40B4-BE49-F238E27FC236}">
+                <a16:creationId xmlns:a16="http://schemas.microsoft.com/office/drawing/2014/main" id="{770CC854-10DC-45BF-A5CA-BB2D624B3B19}"/>
               </a:ext>
             </a:extLst>
           </p:cNvPr>
@@ -5475,8 +5483,8 @@
         </p:blipFill>
         <p:spPr>
           <a:xfrm>
-            <a:off x="838200" y="3429000"/>
-            <a:ext cx="2630238" cy="1381539"/>
+            <a:off x="4410225" y="772888"/>
+            <a:ext cx="6529266" cy="5981246"/>
           </a:xfrm>
           <a:prstGeom prst="rect">
             <a:avLst/>

</xml_diff>